<commit_message>
Update satellite workshop materials and schedule
</commit_message>
<xml_diff>
--- a/images/workshop/AICAS2026-S2CAS-Satellite_Worshop.pptx
+++ b/images/workshop/AICAS2026-S2CAS-Satellite_Worshop.pptx
@@ -197,7 +197,7 @@
           <a:p>
             <a:fld id="{E91B8D7A-2DD8-48AB-98FB-9E4BEB662BB7}" type="datetimeFigureOut">
               <a:rPr lang="zh-CN" altLang="en-US" smtClean="0"/>
-              <a:t>2026/8/24</a:t>
+              <a:t>2026/9/10</a:t>
             </a:fld>
             <a:endParaRPr lang="zh-CN" altLang="en-US"/>
           </a:p>
@@ -679,7 +679,7 @@
           <a:p>
             <a:fld id="{C764DE79-268F-4C1A-8933-263129D2AF90}" type="datetimeFigureOut">
               <a:rPr lang="en-US" dirty="0"/>
-              <a:t>8/24/2026</a:t>
+              <a:t>9/10/2026</a:t>
             </a:fld>
             <a:endParaRPr lang="en-US" dirty="0"/>
           </a:p>
@@ -849,7 +849,7 @@
           <a:p>
             <a:fld id="{C764DE79-268F-4C1A-8933-263129D2AF90}" type="datetimeFigureOut">
               <a:rPr lang="en-US" dirty="0"/>
-              <a:t>8/24/2026</a:t>
+              <a:t>9/10/2026</a:t>
             </a:fld>
             <a:endParaRPr lang="en-US" dirty="0"/>
           </a:p>
@@ -1029,7 +1029,7 @@
           <a:p>
             <a:fld id="{C764DE79-268F-4C1A-8933-263129D2AF90}" type="datetimeFigureOut">
               <a:rPr lang="en-US" dirty="0"/>
-              <a:t>8/24/2026</a:t>
+              <a:t>9/10/2026</a:t>
             </a:fld>
             <a:endParaRPr lang="en-US" dirty="0"/>
           </a:p>
@@ -1199,7 +1199,7 @@
           <a:p>
             <a:fld id="{C764DE79-268F-4C1A-8933-263129D2AF90}" type="datetimeFigureOut">
               <a:rPr lang="en-US" dirty="0"/>
-              <a:t>8/24/2026</a:t>
+              <a:t>9/10/2026</a:t>
             </a:fld>
             <a:endParaRPr lang="en-US" dirty="0"/>
           </a:p>
@@ -1443,7 +1443,7 @@
           <a:p>
             <a:fld id="{C764DE79-268F-4C1A-8933-263129D2AF90}" type="datetimeFigureOut">
               <a:rPr lang="en-US" dirty="0"/>
-              <a:t>8/24/2026</a:t>
+              <a:t>9/10/2026</a:t>
             </a:fld>
             <a:endParaRPr lang="en-US" dirty="0"/>
           </a:p>
@@ -1675,7 +1675,7 @@
           <a:p>
             <a:fld id="{C764DE79-268F-4C1A-8933-263129D2AF90}" type="datetimeFigureOut">
               <a:rPr lang="en-US" dirty="0"/>
-              <a:t>8/24/2026</a:t>
+              <a:t>9/10/2026</a:t>
             </a:fld>
             <a:endParaRPr lang="en-US" dirty="0"/>
           </a:p>
@@ -2042,7 +2042,7 @@
           <a:p>
             <a:fld id="{C764DE79-268F-4C1A-8933-263129D2AF90}" type="datetimeFigureOut">
               <a:rPr lang="en-US" dirty="0"/>
-              <a:t>8/24/2026</a:t>
+              <a:t>9/10/2026</a:t>
             </a:fld>
             <a:endParaRPr lang="en-US" dirty="0"/>
           </a:p>
@@ -2160,7 +2160,7 @@
           <a:p>
             <a:fld id="{C764DE79-268F-4C1A-8933-263129D2AF90}" type="datetimeFigureOut">
               <a:rPr lang="en-US" dirty="0"/>
-              <a:t>8/24/2026</a:t>
+              <a:t>9/10/2026</a:t>
             </a:fld>
             <a:endParaRPr lang="en-US" dirty="0"/>
           </a:p>
@@ -2255,7 +2255,7 @@
           <a:p>
             <a:fld id="{C764DE79-268F-4C1A-8933-263129D2AF90}" type="datetimeFigureOut">
               <a:rPr lang="en-US" dirty="0"/>
-              <a:t>8/24/2026</a:t>
+              <a:t>9/10/2026</a:t>
             </a:fld>
             <a:endParaRPr lang="en-US" dirty="0"/>
           </a:p>
@@ -2532,7 +2532,7 @@
           <a:p>
             <a:fld id="{C764DE79-268F-4C1A-8933-263129D2AF90}" type="datetimeFigureOut">
               <a:rPr lang="en-US" dirty="0"/>
-              <a:t>8/24/2026</a:t>
+              <a:t>9/10/2026</a:t>
             </a:fld>
             <a:endParaRPr lang="en-US" dirty="0"/>
           </a:p>
@@ -2789,7 +2789,7 @@
           <a:p>
             <a:fld id="{C764DE79-268F-4C1A-8933-263129D2AF90}" type="datetimeFigureOut">
               <a:rPr lang="en-US" dirty="0"/>
-              <a:t>8/24/2026</a:t>
+              <a:t>9/10/2026</a:t>
             </a:fld>
             <a:endParaRPr lang="en-US" dirty="0"/>
           </a:p>
@@ -3002,7 +3002,7 @@
           <a:p>
             <a:fld id="{C764DE79-268F-4C1A-8933-263129D2AF90}" type="datetimeFigureOut">
               <a:rPr lang="en-US" dirty="0"/>
-              <a:t>8/24/2026</a:t>
+              <a:t>9/10/2026</a:t>
             </a:fld>
             <a:endParaRPr lang="en-US" dirty="0"/>
           </a:p>
@@ -4495,7 +4495,7 @@
           <p:nvPr>
             <p:extLst>
               <p:ext uri="{D42A27DB-BD31-4B8C-83A1-F6EECF244321}">
-                <p14:modId xmlns:p14="http://schemas.microsoft.com/office/powerpoint/2010/main" val="2846431805"/>
+                <p14:modId xmlns:p14="http://schemas.microsoft.com/office/powerpoint/2010/main" val="2486971598"/>
               </p:ext>
             </p:extLst>
           </p:nvPr>
@@ -4544,7 +4544,7 @@
                           <a:latin typeface="Arial" panose="020B0604020202020204" pitchFamily="34" charset="0"/>
                           <a:cs typeface="Arial" panose="020B0604020202020204" pitchFamily="34" charset="0"/>
                         </a:rPr>
-                        <a:t>1</a:t>
+                        <a:t>2</a:t>
                       </a:r>
                       <a:r>
                         <a:rPr lang="zh-CN" sz="1200" b="0" u="none" strike="noStrike" dirty="0">
@@ -4560,7 +4560,7 @@
                           <a:latin typeface="Arial" panose="020B0604020202020204" pitchFamily="34" charset="0"/>
                           <a:cs typeface="Arial" panose="020B0604020202020204" pitchFamily="34" charset="0"/>
                         </a:rPr>
-                        <a:t>3</a:t>
+                        <a:t>0</a:t>
                       </a:r>
                       <a:r>
                         <a:rPr lang="zh-CN" sz="1200" b="0" u="none" strike="noStrike" dirty="0">
@@ -4576,7 +4576,7 @@
                           <a:latin typeface="Arial" panose="020B0604020202020204" pitchFamily="34" charset="0"/>
                           <a:cs typeface="Arial" panose="020B0604020202020204" pitchFamily="34" charset="0"/>
                         </a:rPr>
-                        <a:t>1</a:t>
+                        <a:t>2</a:t>
                       </a:r>
                       <a:r>
                         <a:rPr lang="zh-CN" sz="1200" b="0" u="none" strike="noStrike" dirty="0">
@@ -4592,7 +4592,7 @@
                           <a:latin typeface="Arial" panose="020B0604020202020204" pitchFamily="34" charset="0"/>
                           <a:cs typeface="Arial" panose="020B0604020202020204" pitchFamily="34" charset="0"/>
                         </a:rPr>
-                        <a:t>40 pm</a:t>
+                        <a:t>10 pm</a:t>
                       </a:r>
                     </a:p>
                     <a:p>
@@ -4608,7 +4608,7 @@
                           <a:latin typeface="Arial" panose="020B0604020202020204" pitchFamily="34" charset="0"/>
                           <a:cs typeface="Arial" panose="020B0604020202020204" pitchFamily="34" charset="0"/>
                         </a:rPr>
-                        <a:t>1:40 – 2:25 pm</a:t>
+                        <a:t>2:10 – 2:45 pm</a:t>
                       </a:r>
                     </a:p>
                     <a:p>
@@ -4637,7 +4637,7 @@
                           <a:latin typeface="Arial" panose="020B0604020202020204" pitchFamily="34" charset="0"/>
                           <a:cs typeface="Arial" panose="020B0604020202020204" pitchFamily="34" charset="0"/>
                         </a:rPr>
-                        <a:t>2:25 – 3:10 pm</a:t>
+                        <a:t>2:45 – 3:20 pm</a:t>
                       </a:r>
                     </a:p>
                     <a:p>
@@ -4666,7 +4666,7 @@
                           <a:latin typeface="Arial" panose="020B0604020202020204" pitchFamily="34" charset="0"/>
                           <a:cs typeface="Arial" panose="020B0604020202020204" pitchFamily="34" charset="0"/>
                         </a:rPr>
-                        <a:t>3:10 – 3:30 pm</a:t>
+                        <a:t>3:20 – 3:50 pm</a:t>
                       </a:r>
                     </a:p>
                     <a:p>
@@ -4682,7 +4682,7 @@
                           <a:latin typeface="Arial" panose="020B0604020202020204" pitchFamily="34" charset="0"/>
                           <a:cs typeface="Arial" panose="020B0604020202020204" pitchFamily="34" charset="0"/>
                         </a:rPr>
-                        <a:t>3:30 – 4:15 pm</a:t>
+                        <a:t>3:50 – 4:25 pm</a:t>
                       </a:r>
                     </a:p>
                     <a:p>
@@ -4724,23 +4724,7 @@
                           <a:latin typeface="Arial" panose="020B0604020202020204" pitchFamily="34" charset="0"/>
                           <a:cs typeface="Arial" panose="020B0604020202020204" pitchFamily="34" charset="0"/>
                         </a:rPr>
-                        <a:t>4:15 </a:t>
-                      </a:r>
-                      <a:r>
-                        <a:rPr lang="en-US" altLang="zh-CN" sz="1200" b="0" u="none" strike="noStrike">
-                          <a:effectLst/>
-                          <a:latin typeface="Arial" panose="020B0604020202020204" pitchFamily="34" charset="0"/>
-                          <a:cs typeface="Arial" panose="020B0604020202020204" pitchFamily="34" charset="0"/>
-                        </a:rPr>
-                        <a:t>– 5:00 </a:t>
-                      </a:r>
-                      <a:r>
-                        <a:rPr lang="en-US" altLang="zh-CN" sz="1200" b="0" u="none" strike="noStrike" dirty="0">
-                          <a:effectLst/>
-                          <a:latin typeface="Arial" panose="020B0604020202020204" pitchFamily="34" charset="0"/>
-                          <a:cs typeface="Arial" panose="020B0604020202020204" pitchFamily="34" charset="0"/>
-                        </a:rPr>
-                        <a:t>pm</a:t>
+                        <a:t>4:25 – 5:00 pm</a:t>
                       </a:r>
                     </a:p>
                     <a:p>

</xml_diff>